<commit_message>
feat(layer-1): production foundation, postgresql migrations, rate limiting, and mission roadmap
</commit_message>
<xml_diff>
--- a/SIH2026_IDEA_Presentation.pptx
+++ b/SIH2026_IDEA_Presentation.pptx
@@ -9428,14 +9428,15 @@
           <a:lstStyle/>
           <a:p>
             <a:pPr eaLnBrk="1" hangingPunct="1">
-              <a:defRPr sz="2200" b="1">
+              <a:defRPr sz="2100" b="1">
                 <a:solidFill>
                   <a:srgbClr val="064E3B"/>
                 </a:solidFill>
+                <a:latin typeface="Times New Roman"/>
               </a:defRPr>
             </a:pPr>
             <a:r>
-              <a:t>FEASIBILITY, RISK MITIGATION &amp; ROADMAP</a:t>
+              <a:t>FEASIBILITY, RISK MITIGATION &amp; PILOT ROADMAP</a:t>
             </a:r>
           </a:p>
         </p:txBody>
@@ -9689,7 +9690,7 @@
         <p:spPr>
           <a:xfrm>
             <a:off x="457200" y="1188720"/>
-            <a:ext cx="5486400" cy="4846320"/>
+            <a:ext cx="5486400" cy="4892040"/>
           </a:xfrm>
           <a:prstGeom prst="roundRect">
             <a:avLst/>
@@ -9697,9 +9698,9 @@
           <a:solidFill>
             <a:srgbClr val="FFFFFF"/>
           </a:solidFill>
-          <a:ln w="22860">
+          <a:ln w="19050">
             <a:solidFill>
-              <a:srgbClr val="10B981"/>
+              <a:srgbClr val="059669"/>
             </a:solidFill>
           </a:ln>
         </p:spPr>
@@ -9733,8 +9734,8 @@
         </p:nvSpPr>
         <p:spPr>
           <a:xfrm>
-            <a:off x="548640" y="1280160"/>
-            <a:ext cx="5303520" cy="347472"/>
+            <a:off x="548640" y="1261872"/>
+            <a:ext cx="5303520" cy="310896"/>
           </a:xfrm>
           <a:prstGeom prst="roundRect">
             <a:avLst/>
@@ -9761,131 +9762,33 @@
           </a:fontRef>
         </p:style>
         <p:txBody>
-          <a:bodyPr rtlCol="0" anchor="ctr" wrap="square"/>
+          <a:bodyPr rtlCol="0" anchor="ctr"/>
           <a:lstStyle/>
           <a:p>
             <a:pPr algn="ctr">
-              <a:defRPr sz="1300" b="1">
+              <a:defRPr sz="1200" b="1">
                 <a:solidFill>
                   <a:srgbClr val="FFFFFF"/>
                 </a:solidFill>
-                <a:latin typeface="Calibri"/>
+                <a:latin typeface="Times New Roman"/>
               </a:defRPr>
             </a:pPr>
             <a:r>
-              <a:t>REAL CHALLENGES &amp; PRACTICAL FIXES</a:t>
-            </a:r>
-          </a:p>
-        </p:txBody>
-      </p:sp>
-      <p:sp>
-        <p:nvSpPr>
-          <p:cNvPr id="17412" name="Rounded Rectangle 17411"/>
-          <p:cNvSpPr/>
-          <p:nvPr/>
-        </p:nvSpPr>
-        <p:spPr>
-          <a:xfrm>
-            <a:off x="594360" y="1719072"/>
-            <a:ext cx="5212080" cy="1280160"/>
-          </a:xfrm>
-          <a:prstGeom prst="roundRect">
-            <a:avLst/>
-          </a:prstGeom>
-          <a:solidFill>
-            <a:srgbClr val="F8FAFC"/>
-          </a:solidFill>
-          <a:ln w="15240">
-            <a:solidFill>
-              <a:srgbClr val="C2410C"/>
-            </a:solidFill>
-          </a:ln>
-        </p:spPr>
-        <p:style>
-          <a:lnRef idx="1">
-            <a:schemeClr val="accent1"/>
-          </a:lnRef>
-          <a:fillRef idx="3">
-            <a:schemeClr val="accent1"/>
-          </a:fillRef>
-          <a:effectRef idx="2">
-            <a:schemeClr val="accent1"/>
-          </a:effectRef>
-          <a:fontRef idx="minor">
-            <a:schemeClr val="lt1"/>
-          </a:fontRef>
-        </p:style>
-        <p:txBody>
-          <a:bodyPr rtlCol="0" anchor="ctr"/>
-          <a:lstStyle/>
-          <a:p>
-            <a:pPr algn="ctr"/>
-          </a:p>
-        </p:txBody>
-      </p:sp>
-      <p:sp>
-        <p:nvSpPr>
-          <p:cNvPr id="17413" name="Rounded Rectangle 17412"/>
-          <p:cNvSpPr/>
-          <p:nvPr/>
-        </p:nvSpPr>
-        <p:spPr>
-          <a:xfrm>
-            <a:off x="685800" y="1792224"/>
-            <a:ext cx="5029200" cy="274320"/>
-          </a:xfrm>
-          <a:prstGeom prst="roundRect">
-            <a:avLst/>
-          </a:prstGeom>
-          <a:solidFill>
-            <a:srgbClr val="C2410C"/>
-          </a:solidFill>
-          <a:ln>
-            <a:noFill/>
-          </a:ln>
-        </p:spPr>
-        <p:style>
-          <a:lnRef idx="1">
-            <a:schemeClr val="accent1"/>
-          </a:lnRef>
-          <a:fillRef idx="3">
-            <a:schemeClr val="accent1"/>
-          </a:fillRef>
-          <a:effectRef idx="2">
-            <a:schemeClr val="accent1"/>
-          </a:effectRef>
-          <a:fontRef idx="minor">
-            <a:schemeClr val="lt1"/>
-          </a:fontRef>
-        </p:style>
-        <p:txBody>
-          <a:bodyPr rtlCol="0" anchor="ctr" wrap="square"/>
-          <a:lstStyle/>
-          <a:p>
-            <a:pPr algn="ctr">
-              <a:defRPr sz="1100" b="1">
-                <a:solidFill>
-                  <a:srgbClr val="FFFFFF"/>
-                </a:solidFill>
-                <a:latin typeface="Calibri"/>
-              </a:defRPr>
-            </a:pPr>
-            <a:r>
-              <a:t>1. Noisy Phone Lines / Rural Dialects</a:t>
-            </a:r>
-          </a:p>
-        </p:txBody>
-      </p:sp>
-      <p:sp>
-        <p:nvSpPr>
-          <p:cNvPr id="17414" name="TextBox 17413"/>
+              <a:t>FEASIBILITY &amp; RISK MITIGATION</a:t>
+            </a:r>
+          </a:p>
+        </p:txBody>
+      </p:sp>
+      <p:sp>
+        <p:nvSpPr>
+          <p:cNvPr id="17412" name="TextBox 17411"/>
           <p:cNvSpPr txBox="1"/>
           <p:nvPr/>
         </p:nvSpPr>
         <p:spPr>
           <a:xfrm>
-            <a:off x="749808" y="2103120"/>
-            <a:ext cx="4892040" cy="822960"/>
+            <a:off x="566928" y="1591056"/>
+            <a:ext cx="5257800" cy="1234440"/>
           </a:xfrm>
           <a:prstGeom prst="rect">
             <a:avLst/>
@@ -9893,152 +9796,102 @@
           <a:noFill/>
         </p:spPr>
         <p:txBody>
-          <a:bodyPr wrap="square" tIns="36576" lIns="36576" rIns="36576" bIns="36576">
+          <a:bodyPr wrap="square" tIns="9144" lIns="9144" rIns="9144">
             <a:spAutoFit/>
           </a:bodyPr>
           <a:lstStyle/>
           <a:p>
             <a:pPr>
               <a:spcAft>
-                <a:spcPts val="600"/>
+                <a:spcPts val="200"/>
               </a:spcAft>
-              <a:defRPr sz="1100">
-                <a:solidFill>
-                  <a:srgbClr val="1E293B"/>
-                </a:solidFill>
-                <a:latin typeface="Calibri"/>
+              <a:defRPr sz="1100" b="1">
+                <a:solidFill>
+                  <a:srgbClr val="064E3B"/>
+                </a:solidFill>
+                <a:latin typeface="Times New Roman"/>
               </a:defRPr>
             </a:pPr>
             <a:r>
-              <a:t>•  Challenge: Background tractor noise can degrade voice STT</a:t>
+              <a:t>⚙️ TECHNICALLY FEASIBLE</a:t>
             </a:r>
           </a:p>
           <a:p>
             <a:pPr>
               <a:spcAft>
-                <a:spcPts val="600"/>
+                <a:spcPts val="150"/>
               </a:spcAft>
-              <a:defRPr sz="1100">
+              <a:defRPr sz="950">
                 <a:solidFill>
                   <a:srgbClr val="1E293B"/>
                 </a:solidFill>
-                <a:latin typeface="Calibri"/>
+                <a:latin typeface="Times New Roman"/>
               </a:defRPr>
             </a:pPr>
             <a:r>
-              <a:t>•  Fix: DTMF keypad menu + Simple SMS fallback (SELL TOMATO 100KG 25)</a:t>
-            </a:r>
-          </a:p>
-        </p:txBody>
-      </p:sp>
-      <p:sp>
-        <p:nvSpPr>
-          <p:cNvPr id="17415" name="Rounded Rectangle 17414"/>
-          <p:cNvSpPr/>
-          <p:nvPr/>
-        </p:nvSpPr>
-        <p:spPr>
-          <a:xfrm>
-            <a:off x="594360" y="3090672"/>
-            <a:ext cx="5212080" cy="1280160"/>
-          </a:xfrm>
-          <a:prstGeom prst="roundRect">
-            <a:avLst/>
-          </a:prstGeom>
-          <a:solidFill>
-            <a:srgbClr val="F8FAFC"/>
-          </a:solidFill>
-          <a:ln w="15240">
-            <a:solidFill>
-              <a:srgbClr val="059669"/>
-            </a:solidFill>
-          </a:ln>
-        </p:spPr>
-        <p:style>
-          <a:lnRef idx="1">
-            <a:schemeClr val="accent1"/>
-          </a:lnRef>
-          <a:fillRef idx="3">
-            <a:schemeClr val="accent1"/>
-          </a:fillRef>
-          <a:effectRef idx="2">
-            <a:schemeClr val="accent1"/>
-          </a:effectRef>
-          <a:fontRef idx="minor">
-            <a:schemeClr val="lt1"/>
-          </a:fontRef>
-        </p:style>
-        <p:txBody>
-          <a:bodyPr rtlCol="0" anchor="ctr"/>
-          <a:lstStyle/>
-          <a:p>
-            <a:pPr algn="ctr"/>
-          </a:p>
-        </p:txBody>
-      </p:sp>
-      <p:sp>
-        <p:nvSpPr>
-          <p:cNvPr id="17416" name="Rounded Rectangle 17415"/>
-          <p:cNvSpPr/>
-          <p:nvPr/>
-        </p:nvSpPr>
-        <p:spPr>
-          <a:xfrm>
-            <a:off x="685800" y="3163824"/>
-            <a:ext cx="5029200" cy="274320"/>
-          </a:xfrm>
-          <a:prstGeom prst="roundRect">
-            <a:avLst/>
-          </a:prstGeom>
-          <a:solidFill>
-            <a:srgbClr val="059669"/>
-          </a:solidFill>
-          <a:ln>
-            <a:noFill/>
-          </a:ln>
-        </p:spPr>
-        <p:style>
-          <a:lnRef idx="1">
-            <a:schemeClr val="accent1"/>
-          </a:lnRef>
-          <a:fillRef idx="3">
-            <a:schemeClr val="accent1"/>
-          </a:fillRef>
-          <a:effectRef idx="2">
-            <a:schemeClr val="accent1"/>
-          </a:effectRef>
-          <a:fontRef idx="minor">
-            <a:schemeClr val="lt1"/>
-          </a:fontRef>
-        </p:style>
-        <p:txBody>
-          <a:bodyPr rtlCol="0" anchor="ctr" wrap="square"/>
-          <a:lstStyle/>
-          <a:p>
-            <a:pPr algn="ctr">
-              <a:defRPr sz="1100" b="1">
-                <a:solidFill>
-                  <a:srgbClr val="FFFFFF"/>
-                </a:solidFill>
-                <a:latin typeface="Calibri"/>
+              <a:t>• Zero hardware barrier — Works on basic ₹800 feature phones via 2G IVR</a:t>
+            </a:r>
+          </a:p>
+          <a:p>
+            <a:pPr>
+              <a:spcAft>
+                <a:spcPts val="150"/>
+              </a:spcAft>
+              <a:defRPr sz="950">
+                <a:solidFill>
+                  <a:srgbClr val="1E293B"/>
+                </a:solidFill>
+                <a:latin typeface="Times New Roman"/>
               </a:defRPr>
             </a:pPr>
             <a:r>
-              <a:t>2. Perishable Crop Spoilage Risk</a:t>
-            </a:r>
-          </a:p>
-        </p:txBody>
-      </p:sp>
-      <p:sp>
-        <p:nvSpPr>
-          <p:cNvPr id="17417" name="TextBox 17416"/>
+              <a:t>• Low compute — Lightweight Node.js/Python services; &lt;2.5s latency</a:t>
+            </a:r>
+          </a:p>
+          <a:p>
+            <a:pPr>
+              <a:spcAft>
+                <a:spcPts val="150"/>
+              </a:spcAft>
+              <a:defRPr sz="950">
+                <a:solidFill>
+                  <a:srgbClr val="1E293B"/>
+                </a:solidFill>
+                <a:latin typeface="Times New Roman"/>
+              </a:defRPr>
+            </a:pPr>
+            <a:r>
+              <a:t>• Open-source stack — React + PostgreSQL/SQLite + Leaflet + OSRM</a:t>
+            </a:r>
+          </a:p>
+          <a:p>
+            <a:pPr>
+              <a:spcAft>
+                <a:spcPts val="150"/>
+              </a:spcAft>
+              <a:defRPr sz="950">
+                <a:solidFill>
+                  <a:srgbClr val="1E293B"/>
+                </a:solidFill>
+                <a:latin typeface="Times New Roman"/>
+              </a:defRPr>
+            </a:pPr>
+            <a:r>
+              <a:t>• Scalable logistics — 2-Opt routing consolidates small farm pickups</a:t>
+            </a:r>
+          </a:p>
+        </p:txBody>
+      </p:sp>
+      <p:sp>
+        <p:nvSpPr>
+          <p:cNvPr id="17413" name="TextBox 17412"/>
           <p:cNvSpPr txBox="1"/>
           <p:nvPr/>
         </p:nvSpPr>
         <p:spPr>
           <a:xfrm>
-            <a:off x="749808" y="3474720"/>
-            <a:ext cx="4892040" cy="822960"/>
+            <a:off x="566928" y="2852928"/>
+            <a:ext cx="5257800" cy="548640"/>
           </a:xfrm>
           <a:prstGeom prst="rect">
             <a:avLst/>
@@ -10046,152 +9899,51 @@
           <a:noFill/>
         </p:spPr>
         <p:txBody>
-          <a:bodyPr wrap="square" tIns="36576" lIns="36576" rIns="36576" bIns="36576">
+          <a:bodyPr wrap="square" tIns="9144" lIns="9144" rIns="9144">
             <a:spAutoFit/>
           </a:bodyPr>
           <a:lstStyle/>
           <a:p>
             <a:pPr>
               <a:spcAft>
-                <a:spcPts val="600"/>
+                <a:spcPts val="200"/>
               </a:spcAft>
-              <a:defRPr sz="1100">
+              <a:defRPr sz="1100" b="1">
+                <a:solidFill>
+                  <a:srgbClr val="C2410C"/>
+                </a:solidFill>
+                <a:latin typeface="Times New Roman"/>
+              </a:defRPr>
+            </a:pPr>
+            <a:r>
+              <a:t>💰 ECONOMICALLY VIABLE</a:t>
+            </a:r>
+          </a:p>
+          <a:p>
+            <a:pPr>
+              <a:defRPr sz="950">
                 <a:solidFill>
                   <a:srgbClr val="1E293B"/>
                 </a:solidFill>
-                <a:latin typeface="Calibri"/>
+                <a:latin typeface="Times New Roman"/>
               </a:defRPr>
             </a:pPr>
             <a:r>
-              <a:t>•  Challenge: Fresh vegetables spoil if not sold in 48-72 hours</a:t>
-            </a:r>
-          </a:p>
-          <a:p>
-            <a:pPr>
-              <a:spcAft>
-                <a:spcPts val="600"/>
-              </a:spcAft>
-              <a:defRPr sz="1100">
-                <a:solidFill>
-                  <a:srgbClr val="1E293B"/>
-                </a:solidFill>
-                <a:latin typeface="Calibri"/>
-              </a:defRPr>
-            </a:pPr>
-            <a:r>
-              <a:t>•  Fix: Auto-discounting urgency deals for local restaurants &amp; bulk buyers</a:t>
-            </a:r>
-          </a:p>
-        </p:txBody>
-      </p:sp>
-      <p:sp>
-        <p:nvSpPr>
-          <p:cNvPr id="17418" name="Rounded Rectangle 17417"/>
-          <p:cNvSpPr/>
-          <p:nvPr/>
-        </p:nvSpPr>
-        <p:spPr>
-          <a:xfrm>
-            <a:off x="594360" y="4462272"/>
-            <a:ext cx="5212080" cy="1280160"/>
-          </a:xfrm>
-          <a:prstGeom prst="roundRect">
-            <a:avLst/>
-          </a:prstGeom>
-          <a:solidFill>
-            <a:srgbClr val="F8FAFC"/>
-          </a:solidFill>
-          <a:ln w="15240">
-            <a:solidFill>
-              <a:srgbClr val="1E40AF"/>
-            </a:solidFill>
-          </a:ln>
-        </p:spPr>
-        <p:style>
-          <a:lnRef idx="1">
-            <a:schemeClr val="accent1"/>
-          </a:lnRef>
-          <a:fillRef idx="3">
-            <a:schemeClr val="accent1"/>
-          </a:fillRef>
-          <a:effectRef idx="2">
-            <a:schemeClr val="accent1"/>
-          </a:effectRef>
-          <a:fontRef idx="minor">
-            <a:schemeClr val="lt1"/>
-          </a:fontRef>
-        </p:style>
-        <p:txBody>
-          <a:bodyPr rtlCol="0" anchor="ctr"/>
-          <a:lstStyle/>
-          <a:p>
-            <a:pPr algn="ctr"/>
-          </a:p>
-        </p:txBody>
-      </p:sp>
-      <p:sp>
-        <p:nvSpPr>
-          <p:cNvPr id="17419" name="Rounded Rectangle 17418"/>
-          <p:cNvSpPr/>
-          <p:nvPr/>
-        </p:nvSpPr>
-        <p:spPr>
-          <a:xfrm>
-            <a:off x="685800" y="4535424"/>
-            <a:ext cx="5029200" cy="274320"/>
-          </a:xfrm>
-          <a:prstGeom prst="roundRect">
-            <a:avLst/>
-          </a:prstGeom>
-          <a:solidFill>
-            <a:srgbClr val="1E40AF"/>
-          </a:solidFill>
-          <a:ln>
-            <a:noFill/>
-          </a:ln>
-        </p:spPr>
-        <p:style>
-          <a:lnRef idx="1">
-            <a:schemeClr val="accent1"/>
-          </a:lnRef>
-          <a:fillRef idx="3">
-            <a:schemeClr val="accent1"/>
-          </a:fillRef>
-          <a:effectRef idx="2">
-            <a:schemeClr val="accent1"/>
-          </a:effectRef>
-          <a:fontRef idx="minor">
-            <a:schemeClr val="lt1"/>
-          </a:fontRef>
-        </p:style>
-        <p:txBody>
-          <a:bodyPr rtlCol="0" anchor="ctr" wrap="square"/>
-          <a:lstStyle/>
-          <a:p>
-            <a:pPr algn="ctr">
-              <a:defRPr sz="1100" b="1">
-                <a:solidFill>
-                  <a:srgbClr val="FFFFFF"/>
-                </a:solidFill>
-                <a:latin typeface="Calibri"/>
-              </a:defRPr>
-            </a:pPr>
-            <a:r>
-              <a:t>3. Fake Listings / Bank Verification</a:t>
-            </a:r>
-          </a:p>
-        </p:txBody>
-      </p:sp>
-      <p:sp>
-        <p:nvSpPr>
-          <p:cNvPr id="17420" name="TextBox 17419"/>
+              <a:t>• 2% transaction fee → covers core platform + communication + mapping costs</a:t>
+            </a:r>
+          </a:p>
+        </p:txBody>
+      </p:sp>
+      <p:sp>
+        <p:nvSpPr>
+          <p:cNvPr id="17414" name="TextBox 17413"/>
           <p:cNvSpPr txBox="1"/>
           <p:nvPr/>
         </p:nvSpPr>
         <p:spPr>
           <a:xfrm>
-            <a:off x="749808" y="4846320"/>
-            <a:ext cx="4892040" cy="822960"/>
+            <a:off x="566928" y="3401568"/>
+            <a:ext cx="5257800" cy="274320"/>
           </a:xfrm>
           <a:prstGeom prst="rect">
             <a:avLst/>
@@ -10199,54 +9951,311 @@
           <a:noFill/>
         </p:spPr>
         <p:txBody>
-          <a:bodyPr wrap="square" tIns="36576" lIns="36576" rIns="36576" bIns="36576">
+          <a:bodyPr wrap="none">
             <a:spAutoFit/>
           </a:bodyPr>
           <a:lstStyle/>
           <a:p>
             <a:pPr>
-              <a:spcAft>
-                <a:spcPts val="600"/>
-              </a:spcAft>
-              <a:defRPr sz="1100">
-                <a:solidFill>
-                  <a:srgbClr val="1E293B"/>
-                </a:solidFill>
-                <a:latin typeface="Calibri"/>
+              <a:defRPr sz="1100" b="1">
+                <a:solidFill>
+                  <a:srgbClr val="1E40AF"/>
+                </a:solidFill>
+                <a:latin typeface="Times New Roman"/>
               </a:defRPr>
             </a:pPr>
             <a:r>
-              <a:t>•  Challenge: Risk of inaccurate listings or invalid bank accounts</a:t>
-            </a:r>
-          </a:p>
-          <a:p>
-            <a:pPr>
-              <a:spcAft>
-                <a:spcPts val="600"/>
-              </a:spcAft>
-              <a:defRPr sz="1100">
-                <a:solidFill>
-                  <a:srgbClr val="1E293B"/>
-                </a:solidFill>
-                <a:latin typeface="Calibri"/>
-              </a:defRPr>
-            </a:pPr>
-            <a:r>
-              <a:t>•  Fix: Driver inspects produce &amp; scans bank passbook at farm gate</a:t>
-            </a:r>
-          </a:p>
-        </p:txBody>
-      </p:sp>
-      <p:sp>
-        <p:nvSpPr>
-          <p:cNvPr id="17421" name="Rounded Rectangle 17420"/>
+              <a:t>🛡️ KEY RISKS → ENGINEERING MITIGATION</a:t>
+            </a:r>
+          </a:p>
+        </p:txBody>
+      </p:sp>
+      <p:graphicFrame>
+        <p:nvGraphicFramePr>
+          <p:cNvPr id="17415" name="Table 17414"/>
+          <p:cNvGraphicFramePr>
+            <a:graphicFrameLocks noGrp="1"/>
+          </p:cNvGraphicFramePr>
+          <p:nvPr/>
+        </p:nvGraphicFramePr>
+        <p:xfrm>
+          <a:off x="566928" y="3694176"/>
+          <a:ext cx="5257800" cy="2240280"/>
+        </p:xfrm>
+        <a:graphic>
+          <a:graphicData uri="http://schemas.openxmlformats.org/drawingml/2006/table">
+            <a:tbl>
+              <a:tblPr firstRow="1" bandRow="1">
+                <a:tableStyleId>{5C22544A-7EE6-4342-B048-85BDC9FD1C3A}</a:tableStyleId>
+              </a:tblPr>
+              <a:tblGrid>
+                <a:gridCol w="2240280"/>
+                <a:gridCol w="3017520"/>
+              </a:tblGrid>
+              <a:tr h="448056">
+                <a:tc>
+                  <a:txBody>
+                    <a:bodyPr/>
+                    <a:lstStyle/>
+                    <a:p>
+                      <a:pPr algn="ctr">
+                        <a:defRPr b="1" sz="1000">
+                          <a:solidFill>
+                            <a:srgbClr val="FFFFFF"/>
+                          </a:solidFill>
+                          <a:latin typeface="Times New Roman"/>
+                        </a:defRPr>
+                      </a:pPr>
+                      <a:r>
+                        <a:t>Challenge</a:t>
+                      </a:r>
+                    </a:p>
+                  </a:txBody>
+                  <a:tcPr>
+                    <a:solidFill>
+                      <a:srgbClr val="1E40AF"/>
+                    </a:solidFill>
+                  </a:tcPr>
+                </a:tc>
+                <a:tc>
+                  <a:txBody>
+                    <a:bodyPr/>
+                    <a:lstStyle/>
+                    <a:p>
+                      <a:pPr algn="ctr">
+                        <a:defRPr b="1" sz="1000">
+                          <a:solidFill>
+                            <a:srgbClr val="FFFFFF"/>
+                          </a:solidFill>
+                          <a:latin typeface="Times New Roman"/>
+                        </a:defRPr>
+                      </a:pPr>
+                      <a:r>
+                        <a:t>Our Mitigation</a:t>
+                      </a:r>
+                    </a:p>
+                  </a:txBody>
+                  <a:tcPr>
+                    <a:solidFill>
+                      <a:srgbClr val="1E40AF"/>
+                    </a:solidFill>
+                  </a:tcPr>
+                </a:tc>
+              </a:tr>
+              <a:tr h="448056">
+                <a:tc>
+                  <a:txBody>
+                    <a:bodyPr/>
+                    <a:lstStyle/>
+                    <a:p>
+                      <a:pPr algn="l">
+                        <a:defRPr sz="900" b="1">
+                          <a:solidFill>
+                            <a:srgbClr val="1E293B"/>
+                          </a:solidFill>
+                          <a:latin typeface="Times New Roman"/>
+                        </a:defRPr>
+                      </a:pPr>
+                      <a:r>
+                        <a:t>🎙️ Noise &amp; rural dialects</a:t>
+                      </a:r>
+                    </a:p>
+                  </a:txBody>
+                  <a:tcPr>
+                    <a:solidFill>
+                      <a:srgbClr val="F8FAFC"/>
+                    </a:solidFill>
+                  </a:tcPr>
+                </a:tc>
+                <a:tc>
+                  <a:txBody>
+                    <a:bodyPr/>
+                    <a:lstStyle/>
+                    <a:p>
+                      <a:pPr algn="l">
+                        <a:defRPr sz="900">
+                          <a:solidFill>
+                            <a:srgbClr val="1E293B"/>
+                          </a:solidFill>
+                          <a:latin typeface="Times New Roman"/>
+                        </a:defRPr>
+                      </a:pPr>
+                      <a:r>
+                        <a:t>IVR + DTMF + SMS fallback</a:t>
+                      </a:r>
+                    </a:p>
+                  </a:txBody>
+                  <a:tcPr>
+                    <a:solidFill>
+                      <a:srgbClr val="F8FAFC"/>
+                    </a:solidFill>
+                  </a:tcPr>
+                </a:tc>
+              </a:tr>
+              <a:tr h="448056">
+                <a:tc>
+                  <a:txBody>
+                    <a:bodyPr/>
+                    <a:lstStyle/>
+                    <a:p>
+                      <a:pPr algn="l">
+                        <a:defRPr sz="900" b="1">
+                          <a:solidFill>
+                            <a:srgbClr val="1E293B"/>
+                          </a:solidFill>
+                          <a:latin typeface="Times New Roman"/>
+                        </a:defRPr>
+                      </a:pPr>
+                      <a:r>
+                        <a:t>🥬 Produce spoilage</a:t>
+                      </a:r>
+                    </a:p>
+                  </a:txBody>
+                  <a:tcPr>
+                    <a:solidFill>
+                      <a:srgbClr val="FFFFFF"/>
+                    </a:solidFill>
+                  </a:tcPr>
+                </a:tc>
+                <a:tc>
+                  <a:txBody>
+                    <a:bodyPr/>
+                    <a:lstStyle/>
+                    <a:p>
+                      <a:pPr algn="l">
+                        <a:defRPr sz="900">
+                          <a:solidFill>
+                            <a:srgbClr val="1E293B"/>
+                          </a:solidFill>
+                          <a:latin typeface="Times New Roman"/>
+                        </a:defRPr>
+                      </a:pPr>
+                      <a:r>
+                        <a:t>Shelf-life engine + 5–15% flash discounts</a:t>
+                      </a:r>
+                    </a:p>
+                  </a:txBody>
+                  <a:tcPr>
+                    <a:solidFill>
+                      <a:srgbClr val="FFFFFF"/>
+                    </a:solidFill>
+                  </a:tcPr>
+                </a:tc>
+              </a:tr>
+              <a:tr h="448056">
+                <a:tc>
+                  <a:txBody>
+                    <a:bodyPr/>
+                    <a:lstStyle/>
+                    <a:p>
+                      <a:pPr algn="l">
+                        <a:defRPr sz="900" b="1">
+                          <a:solidFill>
+                            <a:srgbClr val="1E293B"/>
+                          </a:solidFill>
+                          <a:latin typeface="Times New Roman"/>
+                        </a:defRPr>
+                      </a:pPr>
+                      <a:r>
+                        <a:t>🏦 False listings / bank errors</a:t>
+                      </a:r>
+                    </a:p>
+                  </a:txBody>
+                  <a:tcPr>
+                    <a:solidFill>
+                      <a:srgbClr val="F8FAFC"/>
+                    </a:solidFill>
+                  </a:tcPr>
+                </a:tc>
+                <a:tc>
+                  <a:txBody>
+                    <a:bodyPr/>
+                    <a:lstStyle/>
+                    <a:p>
+                      <a:pPr algn="l">
+                        <a:defRPr sz="900">
+                          <a:solidFill>
+                            <a:srgbClr val="1E293B"/>
+                          </a:solidFill>
+                          <a:latin typeface="Times New Roman"/>
+                        </a:defRPr>
+                      </a:pPr>
+                      <a:r>
+                        <a:t>Farm-gate grading + passbook OCR</a:t>
+                      </a:r>
+                    </a:p>
+                  </a:txBody>
+                  <a:tcPr>
+                    <a:solidFill>
+                      <a:srgbClr val="F8FAFC"/>
+                    </a:solidFill>
+                  </a:tcPr>
+                </a:tc>
+              </a:tr>
+              <a:tr h="448056">
+                <a:tc>
+                  <a:txBody>
+                    <a:bodyPr/>
+                    <a:lstStyle/>
+                    <a:p>
+                      <a:pPr algn="l">
+                        <a:defRPr sz="900" b="1">
+                          <a:solidFill>
+                            <a:srgbClr val="1E293B"/>
+                          </a:solidFill>
+                          <a:latin typeface="Times New Roman"/>
+                        </a:defRPr>
+                      </a:pPr>
+                      <a:r>
+                        <a:t>🚚 Small-lot transport cost</a:t>
+                      </a:r>
+                    </a:p>
+                  </a:txBody>
+                  <a:tcPr>
+                    <a:solidFill>
+                      <a:srgbClr val="FFFFFF"/>
+                    </a:solidFill>
+                  </a:tcPr>
+                </a:tc>
+                <a:tc>
+                  <a:txBody>
+                    <a:bodyPr/>
+                    <a:lstStyle/>
+                    <a:p>
+                      <a:pPr algn="l">
+                        <a:defRPr sz="900">
+                          <a:solidFill>
+                            <a:srgbClr val="1E293B"/>
+                          </a:solidFill>
+                          <a:latin typeface="Times New Roman"/>
+                        </a:defRPr>
+                      </a:pPr>
+                      <a:r>
+                        <a:t>2-Opt clustering within 25 km</a:t>
+                      </a:r>
+                    </a:p>
+                  </a:txBody>
+                  <a:tcPr>
+                    <a:solidFill>
+                      <a:srgbClr val="FFFFFF"/>
+                    </a:solidFill>
+                  </a:tcPr>
+                </a:tc>
+              </a:tr>
+            </a:tbl>
+          </a:graphicData>
+        </a:graphic>
+      </p:graphicFrame>
+      <p:sp>
+        <p:nvSpPr>
+          <p:cNvPr id="17416" name="Rounded Rectangle 17415"/>
           <p:cNvSpPr/>
           <p:nvPr/>
         </p:nvSpPr>
         <p:spPr>
           <a:xfrm>
             <a:off x="6126480" y="1188720"/>
-            <a:ext cx="5577840" cy="4846320"/>
+            <a:ext cx="5577840" cy="4892040"/>
           </a:xfrm>
           <a:prstGeom prst="roundRect">
             <a:avLst/>
@@ -10254,9 +10263,9 @@
           <a:solidFill>
             <a:srgbClr val="F2FDF5"/>
           </a:solidFill>
-          <a:ln w="22860">
+          <a:ln w="19050">
             <a:solidFill>
-              <a:srgbClr val="10B981"/>
+              <a:srgbClr val="059669"/>
             </a:solidFill>
           </a:ln>
         </p:spPr>
@@ -10284,14 +10293,14 @@
       </p:sp>
       <p:sp>
         <p:nvSpPr>
-          <p:cNvPr id="17422" name="Rounded Rectangle 17421"/>
+          <p:cNvPr id="17417" name="Rounded Rectangle 17416"/>
           <p:cNvSpPr/>
           <p:nvPr/>
         </p:nvSpPr>
         <p:spPr>
           <a:xfrm>
-            <a:off x="6217920" y="1280160"/>
-            <a:ext cx="5394960" cy="347472"/>
+            <a:off x="6217920" y="1261872"/>
+            <a:ext cx="5394960" cy="310896"/>
           </a:xfrm>
           <a:prstGeom prst="roundRect">
             <a:avLst/>
@@ -10318,33 +10327,33 @@
           </a:fontRef>
         </p:style>
         <p:txBody>
-          <a:bodyPr rtlCol="0" anchor="ctr" wrap="square"/>
+          <a:bodyPr rtlCol="0" anchor="ctr"/>
           <a:lstStyle/>
           <a:p>
             <a:pPr algn="ctr">
-              <a:defRPr sz="1300" b="1">
+              <a:defRPr sz="1200" b="1">
                 <a:solidFill>
                   <a:srgbClr val="FFFFFF"/>
                 </a:solidFill>
-                <a:latin typeface="Calibri"/>
+                <a:latin typeface="Times New Roman"/>
               </a:defRPr>
             </a:pPr>
             <a:r>
-              <a:t>PHASED PILOT &amp; SCALE ROADMAP</a:t>
-            </a:r>
-          </a:p>
-        </p:txBody>
-      </p:sp>
-      <p:sp>
-        <p:nvSpPr>
-          <p:cNvPr id="17423" name="Rounded Rectangle 17422"/>
+              <a:t>PILOT → SCALE ROADMAP</a:t>
+            </a:r>
+          </a:p>
+        </p:txBody>
+      </p:sp>
+      <p:sp>
+        <p:nvSpPr>
+          <p:cNvPr id="17418" name="Rounded Rectangle 17417"/>
           <p:cNvSpPr/>
           <p:nvPr/>
         </p:nvSpPr>
         <p:spPr>
           <a:xfrm>
-            <a:off x="6263640" y="1719072"/>
-            <a:ext cx="5303520" cy="1280160"/>
+            <a:off x="6263640" y="1627632"/>
+            <a:ext cx="5303520" cy="1298448"/>
           </a:xfrm>
           <a:prstGeom prst="roundRect">
             <a:avLst/>
@@ -10382,14 +10391,14 @@
       </p:sp>
       <p:sp>
         <p:nvSpPr>
-          <p:cNvPr id="17424" name="Rounded Rectangle 17423"/>
+          <p:cNvPr id="17419" name="Rounded Rectangle 17418"/>
           <p:cNvSpPr/>
           <p:nvPr/>
         </p:nvSpPr>
         <p:spPr>
           <a:xfrm>
-            <a:off x="6355080" y="1792224"/>
-            <a:ext cx="5120640" cy="274320"/>
+            <a:off x="6355080" y="1682496"/>
+            <a:ext cx="5120640" cy="256032"/>
           </a:xfrm>
           <a:prstGeom prst="roundRect">
             <a:avLst/>
@@ -10416,33 +10425,33 @@
           </a:fontRef>
         </p:style>
         <p:txBody>
-          <a:bodyPr rtlCol="0" anchor="ctr" wrap="square"/>
+          <a:bodyPr rtlCol="0" anchor="ctr"/>
           <a:lstStyle/>
           <a:p>
             <a:pPr algn="ctr">
-              <a:defRPr sz="1100" b="1">
+              <a:defRPr b="1" sz="1000">
                 <a:solidFill>
                   <a:srgbClr val="FFFFFF"/>
                 </a:solidFill>
-                <a:latin typeface="Calibri"/>
+                <a:latin typeface="Times New Roman"/>
               </a:defRPr>
             </a:pPr>
             <a:r>
-              <a:t>PHASE 1: Working Prototype (DONE ✅)</a:t>
-            </a:r>
-          </a:p>
-        </p:txBody>
-      </p:sp>
-      <p:sp>
-        <p:nvSpPr>
-          <p:cNvPr id="17425" name="TextBox 17424"/>
+              <a:t>🟢 PHASE 1 : PROTOTYPE — DONE (Grand Finale Ready)</a:t>
+            </a:r>
+          </a:p>
+        </p:txBody>
+      </p:sp>
+      <p:sp>
+        <p:nvSpPr>
+          <p:cNvPr id="17420" name="TextBox 17419"/>
           <p:cNvSpPr txBox="1"/>
           <p:nvPr/>
         </p:nvSpPr>
         <p:spPr>
           <a:xfrm>
-            <a:off x="6446520" y="2103120"/>
-            <a:ext cx="4983480" cy="822960"/>
+            <a:off x="6355080" y="1956816"/>
+            <a:ext cx="5120640" cy="896112"/>
           </a:xfrm>
           <a:prstGeom prst="rect">
             <a:avLst/>
@@ -10450,54 +10459,113 @@
           <a:noFill/>
         </p:spPr>
         <p:txBody>
-          <a:bodyPr wrap="square" tIns="36576" lIns="36576" rIns="36576" bIns="36576">
+          <a:bodyPr wrap="square" tIns="9144">
             <a:spAutoFit/>
           </a:bodyPr>
           <a:lstStyle/>
           <a:p>
             <a:pPr>
               <a:spcAft>
-                <a:spcPts val="600"/>
+                <a:spcPts val="150"/>
               </a:spcAft>
-              <a:defRPr sz="1100">
+              <a:defRPr sz="900">
                 <a:solidFill>
                   <a:srgbClr val="1E293B"/>
                 </a:solidFill>
-                <a:latin typeface="Calibri"/>
+                <a:latin typeface="Times New Roman"/>
               </a:defRPr>
             </a:pPr>
             <a:r>
-              <a:t>•  End-to-end 2G IVR voice listing tested on real calls</a:t>
+              <a:t>✓ 2G IVR + Sarvam AI        ✓ 2-Opt Logistics Optimization</a:t>
             </a:r>
           </a:p>
           <a:p>
             <a:pPr>
               <a:spcAft>
-                <a:spcPts val="600"/>
+                <a:spcPts val="150"/>
               </a:spcAft>
-              <a:defRPr sz="1100">
+              <a:defRPr sz="900">
                 <a:solidFill>
                   <a:srgbClr val="1E293B"/>
                 </a:solidFill>
-                <a:latin typeface="Calibri"/>
+                <a:latin typeface="Times New Roman"/>
               </a:defRPr>
             </a:pPr>
             <a:r>
-              <a:t>•  Live APMC price checking, direct marketplace &amp; 2-Opt routing</a:t>
-            </a:r>
-          </a:p>
-        </p:txBody>
-      </p:sp>
-      <p:sp>
-        <p:nvSpPr>
-          <p:cNvPr id="17426" name="Rounded Rectangle 17425"/>
+              <a:t>✓ APMC Price Verification    ✓ Live Leaflet GIS Tracking</a:t>
+            </a:r>
+          </a:p>
+          <a:p>
+            <a:pPr>
+              <a:spcAft>
+                <a:spcPts val="150"/>
+              </a:spcAft>
+              <a:defRPr sz="900">
+                <a:solidFill>
+                  <a:srgbClr val="1E293B"/>
+                </a:solidFill>
+                <a:latin typeface="Times New Roman"/>
+              </a:defRPr>
+            </a:pPr>
+            <a:r>
+              <a:t>✓ Direct Marketplace         ✓ T+0 Digital Escrow Settlement</a:t>
+            </a:r>
+          </a:p>
+        </p:txBody>
+      </p:sp>
+      <p:sp>
+        <p:nvSpPr>
+          <p:cNvPr id="17421" name="Down Arrow 17420"/>
           <p:cNvSpPr/>
           <p:nvPr/>
         </p:nvSpPr>
         <p:spPr>
           <a:xfrm>
-            <a:off x="6263640" y="3090672"/>
-            <a:ext cx="5303520" cy="1280160"/>
+            <a:off x="8823960" y="2944368"/>
+            <a:ext cx="146304" cy="164592"/>
+          </a:xfrm>
+          <a:prstGeom prst="downArrow">
+            <a:avLst/>
+          </a:prstGeom>
+          <a:solidFill>
+            <a:srgbClr val="059669"/>
+          </a:solidFill>
+          <a:ln>
+            <a:noFill/>
+          </a:ln>
+        </p:spPr>
+        <p:style>
+          <a:lnRef idx="1">
+            <a:schemeClr val="accent1"/>
+          </a:lnRef>
+          <a:fillRef idx="3">
+            <a:schemeClr val="accent1"/>
+          </a:fillRef>
+          <a:effectRef idx="2">
+            <a:schemeClr val="accent1"/>
+          </a:effectRef>
+          <a:fontRef idx="minor">
+            <a:schemeClr val="lt1"/>
+          </a:fontRef>
+        </p:style>
+        <p:txBody>
+          <a:bodyPr rtlCol="0" anchor="ctr"/>
+          <a:lstStyle/>
+          <a:p>
+            <a:pPr algn="ctr"/>
+          </a:p>
+        </p:txBody>
+      </p:sp>
+      <p:sp>
+        <p:nvSpPr>
+          <p:cNvPr id="17422" name="Rounded Rectangle 17421"/>
+          <p:cNvSpPr/>
+          <p:nvPr/>
+        </p:nvSpPr>
+        <p:spPr>
+          <a:xfrm>
+            <a:off x="6263640" y="3127248"/>
+            <a:ext cx="5303520" cy="1261872"/>
           </a:xfrm>
           <a:prstGeom prst="roundRect">
             <a:avLst/>
@@ -10535,14 +10603,14 @@
       </p:sp>
       <p:sp>
         <p:nvSpPr>
-          <p:cNvPr id="17427" name="Rounded Rectangle 17426"/>
+          <p:cNvPr id="17423" name="Rounded Rectangle 17422"/>
           <p:cNvSpPr/>
           <p:nvPr/>
         </p:nvSpPr>
         <p:spPr>
           <a:xfrm>
-            <a:off x="6355080" y="3163824"/>
-            <a:ext cx="5120640" cy="274320"/>
+            <a:off x="6355080" y="3182112"/>
+            <a:ext cx="5120640" cy="256032"/>
           </a:xfrm>
           <a:prstGeom prst="roundRect">
             <a:avLst/>
@@ -10569,33 +10637,33 @@
           </a:fontRef>
         </p:style>
         <p:txBody>
-          <a:bodyPr rtlCol="0" anchor="ctr" wrap="square"/>
+          <a:bodyPr rtlCol="0" anchor="ctr"/>
           <a:lstStyle/>
           <a:p>
             <a:pPr algn="ctr">
-              <a:defRPr sz="1100" b="1">
+              <a:defRPr b="1" sz="1000">
                 <a:solidFill>
                   <a:srgbClr val="FFFFFF"/>
                 </a:solidFill>
-                <a:latin typeface="Calibri"/>
+                <a:latin typeface="Times New Roman"/>
               </a:defRPr>
             </a:pPr>
             <a:r>
-              <a:t>PHASE 2: District Pilot (Months 1–4)</a:t>
-            </a:r>
-          </a:p>
-        </p:txBody>
-      </p:sp>
-      <p:sp>
-        <p:nvSpPr>
-          <p:cNvPr id="17428" name="TextBox 17427"/>
+              <a:t>🔵 PHASE 2 : DISTRICT PILOT (Months 1–4)</a:t>
+            </a:r>
+          </a:p>
+        </p:txBody>
+      </p:sp>
+      <p:sp>
+        <p:nvSpPr>
+          <p:cNvPr id="17424" name="TextBox 17423"/>
           <p:cNvSpPr txBox="1"/>
           <p:nvPr/>
         </p:nvSpPr>
         <p:spPr>
           <a:xfrm>
-            <a:off x="6446520" y="3474720"/>
-            <a:ext cx="4983480" cy="822960"/>
+            <a:off x="6355080" y="3456432"/>
+            <a:ext cx="5120640" cy="868680"/>
           </a:xfrm>
           <a:prstGeom prst="rect">
             <a:avLst/>
@@ -10603,54 +10671,113 @@
           <a:noFill/>
         </p:spPr>
         <p:txBody>
-          <a:bodyPr wrap="square" tIns="36576" lIns="36576" rIns="36576" bIns="36576">
+          <a:bodyPr wrap="square" tIns="9144">
             <a:spAutoFit/>
           </a:bodyPr>
           <a:lstStyle/>
           <a:p>
             <a:pPr>
               <a:spcAft>
-                <a:spcPts val="600"/>
+                <a:spcPts val="150"/>
               </a:spcAft>
-              <a:defRPr sz="1100">
+              <a:defRPr sz="900">
                 <a:solidFill>
                   <a:srgbClr val="1E293B"/>
                 </a:solidFill>
-                <a:latin typeface="Calibri"/>
+                <a:latin typeface="Times New Roman"/>
               </a:defRPr>
             </a:pPr>
             <a:r>
-              <a:t>•  500 farmers in Salem / Nashik vegetable clusters</a:t>
+              <a:t>• 500 farmers &amp; 3 FPOs in Salem + Nashik vegetable clusters</a:t>
             </a:r>
           </a:p>
           <a:p>
             <a:pPr>
               <a:spcAft>
-                <a:spcPts val="600"/>
+                <a:spcPts val="150"/>
               </a:spcAft>
-              <a:defRPr sz="1100">
+              <a:defRPr sz="900">
                 <a:solidFill>
                   <a:srgbClr val="1E293B"/>
                 </a:solidFill>
-                <a:latin typeface="Calibri"/>
+                <a:latin typeface="Times New Roman"/>
               </a:defRPr>
             </a:pPr>
             <a:r>
-              <a:t>•  10 shared mini-trucks handling 2,000 monthly orders</a:t>
-            </a:r>
-          </a:p>
-        </p:txBody>
-      </p:sp>
-      <p:sp>
-        <p:nvSpPr>
-          <p:cNvPr id="17429" name="Rounded Rectangle 17428"/>
+              <a:t>• 10 Tata Ace owner-drivers onboarded for shared transport</a:t>
+            </a:r>
+          </a:p>
+          <a:p>
+            <a:pPr>
+              <a:spcAft>
+                <a:spcPts val="150"/>
+              </a:spcAft>
+              <a:defRPr sz="900">
+                <a:solidFill>
+                  <a:srgbClr val="1E293B"/>
+                </a:solidFill>
+                <a:latin typeface="Times New Roman"/>
+              </a:defRPr>
+            </a:pPr>
+            <a:r>
+              <a:t>• Target: 2,000 direct consumer &amp; bulk restaurant orders / month</a:t>
+            </a:r>
+          </a:p>
+        </p:txBody>
+      </p:sp>
+      <p:sp>
+        <p:nvSpPr>
+          <p:cNvPr id="17425" name="Down Arrow 17424"/>
           <p:cNvSpPr/>
           <p:nvPr/>
         </p:nvSpPr>
         <p:spPr>
           <a:xfrm>
-            <a:off x="6263640" y="4462272"/>
-            <a:ext cx="5303520" cy="1280160"/>
+            <a:off x="8823960" y="4407408"/>
+            <a:ext cx="146304" cy="164592"/>
+          </a:xfrm>
+          <a:prstGeom prst="downArrow">
+            <a:avLst/>
+          </a:prstGeom>
+          <a:solidFill>
+            <a:srgbClr val="1E40AF"/>
+          </a:solidFill>
+          <a:ln>
+            <a:noFill/>
+          </a:ln>
+        </p:spPr>
+        <p:style>
+          <a:lnRef idx="1">
+            <a:schemeClr val="accent1"/>
+          </a:lnRef>
+          <a:fillRef idx="3">
+            <a:schemeClr val="accent1"/>
+          </a:fillRef>
+          <a:effectRef idx="2">
+            <a:schemeClr val="accent1"/>
+          </a:effectRef>
+          <a:fontRef idx="minor">
+            <a:schemeClr val="lt1"/>
+          </a:fontRef>
+        </p:style>
+        <p:txBody>
+          <a:bodyPr rtlCol="0" anchor="ctr"/>
+          <a:lstStyle/>
+          <a:p>
+            <a:pPr algn="ctr"/>
+          </a:p>
+        </p:txBody>
+      </p:sp>
+      <p:sp>
+        <p:nvSpPr>
+          <p:cNvPr id="17426" name="Rounded Rectangle 17425"/>
+          <p:cNvSpPr/>
+          <p:nvPr/>
+        </p:nvSpPr>
+        <p:spPr>
+          <a:xfrm>
+            <a:off x="6263640" y="4590288"/>
+            <a:ext cx="5303520" cy="1371600"/>
           </a:xfrm>
           <a:prstGeom prst="roundRect">
             <a:avLst/>
@@ -10688,14 +10815,14 @@
       </p:sp>
       <p:sp>
         <p:nvSpPr>
-          <p:cNvPr id="17430" name="Rounded Rectangle 17429"/>
+          <p:cNvPr id="17427" name="Rounded Rectangle 17426"/>
           <p:cNvSpPr/>
           <p:nvPr/>
         </p:nvSpPr>
         <p:spPr>
           <a:xfrm>
-            <a:off x="6355080" y="4535424"/>
-            <a:ext cx="5120640" cy="274320"/>
+            <a:off x="6355080" y="4645152"/>
+            <a:ext cx="5120640" cy="256032"/>
           </a:xfrm>
           <a:prstGeom prst="roundRect">
             <a:avLst/>
@@ -10722,33 +10849,33 @@
           </a:fontRef>
         </p:style>
         <p:txBody>
-          <a:bodyPr rtlCol="0" anchor="ctr" wrap="square"/>
+          <a:bodyPr rtlCol="0" anchor="ctr"/>
           <a:lstStyle/>
           <a:p>
             <a:pPr algn="ctr">
-              <a:defRPr sz="1100" b="1">
+              <a:defRPr b="1" sz="1000">
                 <a:solidFill>
                   <a:srgbClr val="FFFFFF"/>
                 </a:solidFill>
-                <a:latin typeface="Calibri"/>
+                <a:latin typeface="Times New Roman"/>
               </a:defRPr>
             </a:pPr>
             <a:r>
-              <a:t>PHASE 3: State Federation (Months 5–12)</a:t>
-            </a:r>
-          </a:p>
-        </p:txBody>
-      </p:sp>
-      <p:sp>
-        <p:nvSpPr>
-          <p:cNvPr id="17431" name="TextBox 17430"/>
+              <a:t>🟠 PHASE 3 : STATE FEDERATION (Months 5–12)</a:t>
+            </a:r>
+          </a:p>
+        </p:txBody>
+      </p:sp>
+      <p:sp>
+        <p:nvSpPr>
+          <p:cNvPr id="17428" name="TextBox 17427"/>
           <p:cNvSpPr txBox="1"/>
           <p:nvPr/>
         </p:nvSpPr>
         <p:spPr>
           <a:xfrm>
-            <a:off x="6446520" y="4846320"/>
-            <a:ext cx="4983480" cy="822960"/>
+            <a:off x="6355080" y="4919472"/>
+            <a:ext cx="5120640" cy="960120"/>
           </a:xfrm>
           <a:prstGeom prst="rect">
             <a:avLst/>
@@ -10756,40 +10883,56 @@
           <a:noFill/>
         </p:spPr>
         <p:txBody>
-          <a:bodyPr wrap="square" tIns="36576" lIns="36576" rIns="36576" bIns="36576">
+          <a:bodyPr wrap="square" tIns="9144">
             <a:spAutoFit/>
           </a:bodyPr>
           <a:lstStyle/>
           <a:p>
             <a:pPr>
               <a:spcAft>
-                <a:spcPts val="600"/>
+                <a:spcPts val="150"/>
               </a:spcAft>
-              <a:defRPr sz="1100">
+              <a:defRPr sz="900">
                 <a:solidFill>
                   <a:srgbClr val="1E293B"/>
                 </a:solidFill>
-                <a:latin typeface="Calibri"/>
+                <a:latin typeface="Times New Roman"/>
               </a:defRPr>
             </a:pPr>
             <a:r>
-              <a:t>•  50+ FPOs &amp; restaurant wholesale networks across 5 states</a:t>
+              <a:t>• Onboard 50+ FPOs across 5 agricultural states (TN, MH, AP, KA, PB)</a:t>
             </a:r>
           </a:p>
           <a:p>
             <a:pPr>
               <a:spcAft>
-                <a:spcPts val="600"/>
+                <a:spcPts val="150"/>
               </a:spcAft>
-              <a:defRPr sz="1100">
+              <a:defRPr sz="900">
                 <a:solidFill>
                   <a:srgbClr val="1E293B"/>
                 </a:solidFill>
-                <a:latin typeface="Calibri"/>
+                <a:latin typeface="Times New Roman"/>
               </a:defRPr>
             </a:pPr>
             <a:r>
-              <a:t>•  Target ₹10 Crore monthly Gross Merchandise Value</a:t>
+              <a:t>• Institutional buyers: Canteen chains, hostels, and kirana networks</a:t>
+            </a:r>
+          </a:p>
+          <a:p>
+            <a:pPr>
+              <a:spcAft>
+                <a:spcPts val="150"/>
+              </a:spcAft>
+              <a:defRPr sz="900">
+                <a:solidFill>
+                  <a:srgbClr val="1E293B"/>
+                </a:solidFill>
+                <a:latin typeface="Times New Roman"/>
+              </a:defRPr>
+            </a:pPr>
+            <a:r>
+              <a:t>• Financial Target: ₹10 Crore / month Gross Merchandise Value (GMV)</a:t>
             </a:r>
           </a:p>
         </p:txBody>

</xml_diff>